<commit_message>
fix: set title strictly to The Vocalis Chronicle, re-structure parallel sentence contrast cohorts, and remove author/PPT references
</commit_message>
<xml_diff>
--- a/Vocalis_Business_Presentation_v4_Vaibhav_Balram.pptx
+++ b/Vocalis_Business_Presentation_v4_Vaibhav_Balram.pptx
@@ -3431,7 +3431,7 @@
               </a:defRPr>
             </a:pPr>
             <a:r>
-              <a:t>PRESENTED BY</a:t>
+              <a:t>SYSTEM ARCHITECTURE</a:t>
             </a:r>
           </a:p>
           <a:p>
@@ -3453,7 +3453,7 @@
               </a:defRPr>
             </a:pPr>
             <a:r>
-              <a:t>Vaibhav &amp; Balram</a:t>
+              <a:t>Tri-Modal Cognitive Engine</a:t>
             </a:r>
           </a:p>
         </p:txBody>
@@ -4453,7 +4453,7 @@
               </a:defRPr>
             </a:pPr>
             <a:r>
-              <a:t>Vocalis POC  |  Tri-Modal System One Architecture &amp; Dual UIs  |  Vaibhav &amp; Balram</a:t>
+              <a:t>Vocalis POC  |  Tri-Modal System One Architecture &amp; Dual UIs</a:t>
             </a:r>
           </a:p>
         </p:txBody>
@@ -5793,7 +5793,7 @@
               </a:defRPr>
             </a:pPr>
             <a:r>
-              <a:t>Vocalis POC  |  Tri-Modal System One Architecture &amp; Dual UIs  |  Vaibhav &amp; Balram</a:t>
+              <a:t>Vocalis POC  |  Tri-Modal System One Architecture &amp; Dual UIs</a:t>
             </a:r>
           </a:p>
         </p:txBody>
@@ -6737,7 +6737,7 @@
               </a:defRPr>
             </a:pPr>
             <a:r>
-              <a:t>Vocalis POC  |  Tri-Modal System One Architecture &amp; Dual UIs  |  Vaibhav &amp; Balram</a:t>
+              <a:t>Vocalis POC  |  Tri-Modal System One Architecture &amp; Dual UIs</a:t>
             </a:r>
           </a:p>
         </p:txBody>
@@ -7811,7 +7811,7 @@
               </a:defRPr>
             </a:pPr>
             <a:r>
-              <a:t>Vocalis POC  |  Tri-Modal System One Architecture &amp; Dual UIs  |  Vaibhav &amp; Balram</a:t>
+              <a:t>Vocalis POC  |  Tri-Modal System One Architecture &amp; Dual UIs</a:t>
             </a:r>
           </a:p>
         </p:txBody>
@@ -8894,7 +8894,7 @@
               </a:defRPr>
             </a:pPr>
             <a:r>
-              <a:t>Vocalis POC  |  Tri-Modal System One Architecture &amp; Dual UIs  |  Vaibhav &amp; Balram</a:t>
+              <a:t>Vocalis POC  |  Tri-Modal System One Architecture &amp; Dual UIs</a:t>
             </a:r>
           </a:p>
         </p:txBody>
@@ -10130,7 +10130,7 @@
               </a:defRPr>
             </a:pPr>
             <a:r>
-              <a:t>Vocalis POC  |  Tri-Modal System One Architecture &amp; Dual UIs  |  Vaibhav &amp; Balram</a:t>
+              <a:t>Vocalis POC  |  Tri-Modal System One Architecture &amp; Dual UIs</a:t>
             </a:r>
           </a:p>
         </p:txBody>
@@ -10717,7 +10717,7 @@
               </a:defRPr>
             </a:pPr>
             <a:r>
-              <a:t>Vocalis POC  |  Tri-Modal System One Architecture &amp; Dual UIs  |  Vaibhav &amp; Balram</a:t>
+              <a:t>Vocalis POC  |  Tri-Modal System One Architecture &amp; Dual UIs</a:t>
             </a:r>
           </a:p>
         </p:txBody>
@@ -11899,7 +11899,7 @@
               </a:defRPr>
             </a:pPr>
             <a:r>
-              <a:t>Vocalis POC  |  Tri-Modal System One Architecture &amp; Dual UIs  |  Vaibhav &amp; Balram</a:t>
+              <a:t>Vocalis POC  |  Tri-Modal System One Architecture &amp; Dual UIs</a:t>
             </a:r>
           </a:p>
         </p:txBody>
@@ -13072,7 +13072,7 @@
               </a:defRPr>
             </a:pPr>
             <a:r>
-              <a:t>Vocalis POC  |  Tri-Modal System One Architecture &amp; Dual UIs  |  Vaibhav &amp; Balram</a:t>
+              <a:t>Vocalis POC  |  Tri-Modal System One Architecture &amp; Dual UIs</a:t>
             </a:r>
           </a:p>
         </p:txBody>
@@ -14776,7 +14776,7 @@
               </a:defRPr>
             </a:pPr>
             <a:r>
-              <a:t>Vocalis POC  |  Tri-Modal System One Architecture &amp; Dual UIs  |  Vaibhav &amp; Balram</a:t>
+              <a:t>Vocalis POC  |  Tri-Modal System One Architecture &amp; Dual UIs</a:t>
             </a:r>
           </a:p>
         </p:txBody>
@@ -15766,7 +15766,7 @@
               </a:defRPr>
             </a:pPr>
             <a:r>
-              <a:t>Thank You  |  Vocalis POC Presentation by Vaibhav &amp; Balram  |  Live Demo Running at http://localhost:5173</a:t>
+              <a:t>Thank You  |  Vocalis POC Architecture &amp; Technical Briefing  |  Live Demo Running at http://localhost:5173</a:t>
             </a:r>
           </a:p>
         </p:txBody>
@@ -15979,7 +15979,7 @@
               </a:defRPr>
             </a:pPr>
             <a:r>
-              <a:t>Vocalis POC  |  Tri-Modal System One Architecture &amp; Dual UIs  |  Vaibhav &amp; Balram</a:t>
+              <a:t>Vocalis POC  |  Tri-Modal System One Architecture &amp; Dual UIs</a:t>
             </a:r>
           </a:p>
         </p:txBody>
@@ -16880,7 +16880,7 @@
               </a:defRPr>
             </a:pPr>
             <a:r>
-              <a:t>Vocalis POC  |  Tri-Modal System One Architecture &amp; Dual UIs  |  Vaibhav &amp; Balram</a:t>
+              <a:t>Vocalis POC  |  Tri-Modal System One Architecture &amp; Dual UIs</a:t>
             </a:r>
           </a:p>
         </p:txBody>
@@ -18373,7 +18373,7 @@
               </a:defRPr>
             </a:pPr>
             <a:r>
-              <a:t>Vocalis POC  |  Tri-Modal System One Architecture &amp; Dual UIs  |  Vaibhav &amp; Balram</a:t>
+              <a:t>Vocalis POC  |  Tri-Modal System One Architecture &amp; Dual UIs</a:t>
             </a:r>
           </a:p>
         </p:txBody>
@@ -19255,7 +19255,7 @@
               </a:defRPr>
             </a:pPr>
             <a:r>
-              <a:t>Vocalis POC  |  Tri-Modal System One Architecture &amp; Dual UIs  |  Vaibhav &amp; Balram</a:t>
+              <a:t>Vocalis POC  |  Tri-Modal System One Architecture &amp; Dual UIs</a:t>
             </a:r>
           </a:p>
         </p:txBody>
@@ -20010,7 +20010,7 @@
               </a:defRPr>
             </a:pPr>
             <a:r>
-              <a:t>Vocalis POC  |  Tri-Modal System One Architecture &amp; Dual UIs  |  Vaibhav &amp; Balram</a:t>
+              <a:t>Vocalis POC  |  Tri-Modal System One Architecture &amp; Dual UIs</a:t>
             </a:r>
           </a:p>
         </p:txBody>
@@ -20823,7 +20823,7 @@
               </a:defRPr>
             </a:pPr>
             <a:r>
-              <a:t>Vocalis POC  |  Tri-Modal System One Architecture &amp; Dual UIs  |  Vaibhav &amp; Balram</a:t>
+              <a:t>Vocalis POC  |  Tri-Modal System One Architecture &amp; Dual UIs</a:t>
             </a:r>
           </a:p>
         </p:txBody>
@@ -21876,7 +21876,7 @@
               </a:defRPr>
             </a:pPr>
             <a:r>
-              <a:t>Vocalis POC  |  Tri-Modal System One Architecture &amp; Dual UIs  |  Vaibhav &amp; Balram</a:t>
+              <a:t>Vocalis POC  |  Tri-Modal System One Architecture &amp; Dual UIs</a:t>
             </a:r>
           </a:p>
         </p:txBody>
@@ -22757,7 +22757,7 @@
               </a:defRPr>
             </a:pPr>
             <a:r>
-              <a:t>Vocalis POC  |  Tri-Modal System One Architecture &amp; Dual UIs  |  Vaibhav &amp; Balram</a:t>
+              <a:t>Vocalis POC  |  Tri-Modal System One Architecture &amp; Dual UIs</a:t>
             </a:r>
           </a:p>
         </p:txBody>

</xml_diff>